<commit_message>
support de soutenance aux couleurs du site
</commit_message>
<xml_diff>
--- a/docs/YIA_Jobs_soutenance.pptx
+++ b/docs/YIA_Jobs_soutenance.pptx
@@ -4912,7 +4912,7 @@
     <p:bg>
       <p:bgPr>
         <a:solidFill>
-          <a:srgbClr val="0B1016"/>
+          <a:srgbClr val="F7F9FB"/>
         </a:solidFill>
         <a:effectLst/>
       </p:bgPr>
@@ -4967,7 +4967,7 @@
             <a:r>
               <a:rPr lang="fr-FR" sz="2000">
                 <a:solidFill>
-                  <a:srgbClr val="F2F5F8"/>
+                  <a:srgbClr val="1D1D1F"/>
                 </a:solidFill>
                 <a:latin typeface="Manrope SemiBold" pitchFamily="2" charset="0"/>
               </a:rPr>
@@ -4976,7 +4976,7 @@
             <a:r>
               <a:rPr lang="fr-FR" sz="2000">
                 <a:solidFill>
-                  <a:srgbClr val="A9CCE3"/>
+                  <a:srgbClr val="24577A"/>
                 </a:solidFill>
                 <a:latin typeface="Manrope SemiBold" pitchFamily="2" charset="0"/>
               </a:rPr>
@@ -4985,7 +4985,7 @@
             <a:r>
               <a:rPr lang="fr-FR" sz="2000">
                 <a:solidFill>
-                  <a:srgbClr val="F2F5F8"/>
+                  <a:srgbClr val="1D1D1F"/>
                 </a:solidFill>
                 <a:latin typeface="Manrope SemiBold" pitchFamily="2" charset="0"/>
               </a:rPr>
@@ -5025,7 +5025,7 @@
             <a:r>
               <a:rPr lang="fr-FR" sz="5800" spc="-100">
                 <a:solidFill>
-                  <a:srgbClr val="F2F5F8"/>
+                  <a:srgbClr val="1D1D1F"/>
                 </a:solidFill>
                 <a:latin typeface="Manrope SemiBold" pitchFamily="2" charset="0"/>
               </a:rPr>
@@ -5036,7 +5036,7 @@
             <a:r>
               <a:rPr lang="fr-FR" sz="5800" spc="-100">
                 <a:solidFill>
-                  <a:srgbClr val="F2F5F8"/>
+                  <a:srgbClr val="1D1D1F"/>
                 </a:solidFill>
                 <a:latin typeface="Manrope SemiBold" pitchFamily="2" charset="0"/>
               </a:rPr>
@@ -5047,10 +5047,10 @@
                 <a:gradFill flip="none" rotWithShape="1">
                   <a:gsLst>
                     <a:gs pos="0">
-                      <a:srgbClr val="5A93BF"/>
+                      <a:srgbClr val="24577A"/>
                     </a:gs>
                     <a:gs pos="100000">
-                      <a:srgbClr val="A9CCE3"/>
+                      <a:srgbClr val="24577A"/>
                     </a:gs>
                   </a:gsLst>
                   <a:lin ang="0" scaled="1"/>
@@ -5063,7 +5063,7 @@
             <a:r>
               <a:rPr lang="fr-FR" sz="5800" spc="-100">
                 <a:solidFill>
-                  <a:srgbClr val="F2F5F8"/>
+                  <a:srgbClr val="1D1D1F"/>
                 </a:solidFill>
                 <a:latin typeface="Manrope SemiBold" pitchFamily="2" charset="0"/>
               </a:rPr>
@@ -5108,7 +5108,7 @@
             <a:r>
               <a:rPr lang="fr-FR" sz="1400">
                 <a:solidFill>
-                  <a:srgbClr val="9CA9B6"/>
+                  <a:srgbClr val="5F6B76"/>
                 </a:solidFill>
                 <a:latin typeface="Manrope" pitchFamily="2" charset="0"/>
               </a:rPr>
@@ -5153,7 +5153,7 @@
             <a:r>
               <a:rPr lang="fr-FR" sz="1400">
                 <a:solidFill>
-                  <a:srgbClr val="F2F5F8"/>
+                  <a:srgbClr val="1D1D1F"/>
                 </a:solidFill>
                 <a:latin typeface="Manrope Medium" pitchFamily="2" charset="0"/>
               </a:rPr>
@@ -5390,7 +5390,7 @@
     <p:bg>
       <p:bgPr>
         <a:solidFill>
-          <a:srgbClr val="0B1016"/>
+          <a:srgbClr val="F7F9FB"/>
         </a:solidFill>
         <a:effectLst/>
       </p:bgPr>
@@ -5445,7 +5445,7 @@
             <a:r>
               <a:rPr lang="fr-FR" sz="1100" spc="260">
                 <a:solidFill>
-                  <a:srgbClr val="A9CCE3"/>
+                  <a:srgbClr val="24577A"/>
                 </a:solidFill>
                 <a:latin typeface="Manrope SemiBold" pitchFamily="2" charset="0"/>
               </a:rPr>
@@ -5485,7 +5485,7 @@
             <a:r>
               <a:rPr lang="fr-FR" sz="3600" spc="-50">
                 <a:solidFill>
-                  <a:srgbClr val="F2F5F8"/>
+                  <a:srgbClr val="1D1D1F"/>
                 </a:solidFill>
                 <a:latin typeface="Manrope SemiBold" pitchFamily="2" charset="0"/>
               </a:rPr>
@@ -5496,10 +5496,10 @@
                 <a:gradFill flip="none" rotWithShape="1">
                   <a:gsLst>
                     <a:gs pos="0">
-                      <a:srgbClr val="5A93BF"/>
+                      <a:srgbClr val="24577A"/>
                     </a:gs>
                     <a:gs pos="100000">
-                      <a:srgbClr val="A9CCE3"/>
+                      <a:srgbClr val="24577A"/>
                     </a:gs>
                   </a:gsLst>
                   <a:lin ang="0" scaled="1"/>
@@ -5512,7 +5512,7 @@
             <a:r>
               <a:rPr lang="fr-FR" sz="3600" spc="-50">
                 <a:solidFill>
-                  <a:srgbClr val="F2F5F8"/>
+                  <a:srgbClr val="1D1D1F"/>
                 </a:solidFill>
                 <a:latin typeface="Manrope SemiBold" pitchFamily="2" charset="0"/>
               </a:rPr>
@@ -5557,7 +5557,7 @@
             <a:r>
               <a:rPr lang="fr-FR" sz="1500">
                 <a:solidFill>
-                  <a:srgbClr val="A9CCE3"/>
+                  <a:srgbClr val="24577A"/>
                 </a:solidFill>
                 <a:latin typeface="Manrope SemiBold" pitchFamily="2" charset="0"/>
               </a:rPr>
@@ -5602,7 +5602,7 @@
             <a:r>
               <a:rPr lang="fr-FR" sz="2100">
                 <a:solidFill>
-                  <a:srgbClr val="F2F5F8"/>
+                  <a:srgbClr val="1D1D1F"/>
                 </a:solidFill>
                 <a:latin typeface="Manrope Medium" pitchFamily="2" charset="0"/>
               </a:rPr>
@@ -5632,7 +5632,7 @@
             <a:avLst/>
           </a:prstGeom>
           <a:solidFill>
-            <a:srgbClr val="243040"/>
+            <a:srgbClr val="E2E8ED"/>
           </a:solidFill>
           <a:ln w="19050" cap="flat" cmpd="sng" algn="ctr">
             <a:noFill/>
@@ -5715,7 +5715,7 @@
             <a:r>
               <a:rPr lang="fr-FR" sz="1500">
                 <a:solidFill>
-                  <a:srgbClr val="A9CCE3"/>
+                  <a:srgbClr val="24577A"/>
                 </a:solidFill>
                 <a:latin typeface="Manrope SemiBold" pitchFamily="2" charset="0"/>
               </a:rPr>
@@ -5760,7 +5760,7 @@
             <a:r>
               <a:rPr lang="fr-FR" sz="2100">
                 <a:solidFill>
-                  <a:srgbClr val="F2F5F8"/>
+                  <a:srgbClr val="1D1D1F"/>
                 </a:solidFill>
                 <a:latin typeface="Manrope Medium" pitchFamily="2" charset="0"/>
               </a:rPr>
@@ -5790,7 +5790,7 @@
             <a:avLst/>
           </a:prstGeom>
           <a:solidFill>
-            <a:srgbClr val="243040"/>
+            <a:srgbClr val="E2E8ED"/>
           </a:solidFill>
           <a:ln w="19050" cap="flat" cmpd="sng" algn="ctr">
             <a:noFill/>
@@ -5873,7 +5873,7 @@
             <a:r>
               <a:rPr lang="fr-FR" sz="1500">
                 <a:solidFill>
-                  <a:srgbClr val="A9CCE3"/>
+                  <a:srgbClr val="24577A"/>
                 </a:solidFill>
                 <a:latin typeface="Manrope SemiBold" pitchFamily="2" charset="0"/>
               </a:rPr>
@@ -5918,7 +5918,7 @@
             <a:r>
               <a:rPr lang="fr-FR" sz="2100">
                 <a:solidFill>
-                  <a:srgbClr val="F2F5F8"/>
+                  <a:srgbClr val="1D1D1F"/>
                 </a:solidFill>
                 <a:latin typeface="Manrope Medium" pitchFamily="2" charset="0"/>
               </a:rPr>
@@ -5948,7 +5948,7 @@
             <a:avLst/>
           </a:prstGeom>
           <a:solidFill>
-            <a:srgbClr val="243040"/>
+            <a:srgbClr val="E2E8ED"/>
           </a:solidFill>
           <a:ln w="19050" cap="flat" cmpd="sng" algn="ctr">
             <a:noFill/>
@@ -6031,7 +6031,7 @@
             <a:r>
               <a:rPr lang="fr-FR" sz="1500">
                 <a:solidFill>
-                  <a:srgbClr val="A9CCE3"/>
+                  <a:srgbClr val="24577A"/>
                 </a:solidFill>
                 <a:latin typeface="Manrope SemiBold" pitchFamily="2" charset="0"/>
               </a:rPr>
@@ -6076,7 +6076,7 @@
             <a:r>
               <a:rPr lang="fr-FR" sz="2100">
                 <a:solidFill>
-                  <a:srgbClr val="F2F5F8"/>
+                  <a:srgbClr val="1D1D1F"/>
                 </a:solidFill>
                 <a:latin typeface="Manrope Medium" pitchFamily="2" charset="0"/>
               </a:rPr>
@@ -6106,7 +6106,7 @@
             <a:avLst/>
           </a:prstGeom>
           <a:solidFill>
-            <a:srgbClr val="243040"/>
+            <a:srgbClr val="E2E8ED"/>
           </a:solidFill>
           <a:ln w="19050" cap="flat" cmpd="sng" algn="ctr">
             <a:noFill/>
@@ -6189,7 +6189,7 @@
             <a:r>
               <a:rPr lang="fr-FR" sz="1500">
                 <a:solidFill>
-                  <a:srgbClr val="A9CCE3"/>
+                  <a:srgbClr val="24577A"/>
                 </a:solidFill>
                 <a:latin typeface="Manrope SemiBold" pitchFamily="2" charset="0"/>
               </a:rPr>
@@ -6234,7 +6234,7 @@
             <a:r>
               <a:rPr lang="fr-FR" sz="2100">
                 <a:solidFill>
-                  <a:srgbClr val="F2F5F8"/>
+                  <a:srgbClr val="1D1D1F"/>
                 </a:solidFill>
                 <a:latin typeface="Manrope Medium" pitchFamily="2" charset="0"/>
               </a:rPr>
@@ -6264,7 +6264,7 @@
             <a:avLst/>
           </a:prstGeom>
           <a:solidFill>
-            <a:srgbClr val="243040"/>
+            <a:srgbClr val="E2E8ED"/>
           </a:solidFill>
           <a:ln w="19050" cap="flat" cmpd="sng" algn="ctr">
             <a:noFill/>
@@ -7007,7 +7007,7 @@
     <p:bg>
       <p:bgPr>
         <a:solidFill>
-          <a:srgbClr val="0B1016"/>
+          <a:srgbClr val="F7F9FB"/>
         </a:solidFill>
         <a:effectLst/>
       </p:bgPr>
@@ -7062,7 +7062,7 @@
             <a:r>
               <a:rPr lang="fr-FR" sz="1100" spc="260">
                 <a:solidFill>
-                  <a:srgbClr val="A9CCE3"/>
+                  <a:srgbClr val="24577A"/>
                 </a:solidFill>
                 <a:latin typeface="Manrope SemiBold" pitchFamily="2" charset="0"/>
               </a:rPr>
@@ -7102,7 +7102,7 @@
             <a:r>
               <a:rPr lang="fr-FR" sz="3600" spc="-50" dirty="0">
                 <a:solidFill>
-                  <a:srgbClr val="F2F5F8"/>
+                  <a:srgbClr val="1D1D1F"/>
                 </a:solidFill>
                 <a:latin typeface="Manrope SemiBold" pitchFamily="2" charset="0"/>
               </a:rPr>
@@ -7113,10 +7113,10 @@
                 <a:gradFill flip="none" rotWithShape="1">
                   <a:gsLst>
                     <a:gs pos="0">
-                      <a:srgbClr val="5A93BF"/>
+                      <a:srgbClr val="24577A"/>
                     </a:gs>
                     <a:gs pos="100000">
-                      <a:srgbClr val="A9CCE3"/>
+                      <a:srgbClr val="24577A"/>
                     </a:gs>
                   </a:gsLst>
                   <a:lin ang="0" scaled="1"/>
@@ -7129,7 +7129,7 @@
             <a:r>
               <a:rPr lang="fr-FR" sz="3600" spc="-50" dirty="0">
                 <a:solidFill>
-                  <a:srgbClr val="F2F5F8"/>
+                  <a:srgbClr val="1D1D1F"/>
                 </a:solidFill>
                 <a:latin typeface="Manrope SemiBold" pitchFamily="2" charset="0"/>
               </a:rPr>
@@ -7169,7 +7169,7 @@
             <a:r>
               <a:rPr lang="fr-FR" sz="4800" dirty="0">
                 <a:solidFill>
-                  <a:srgbClr val="F2F5F8"/>
+                  <a:srgbClr val="1D1D1F"/>
                 </a:solidFill>
                 <a:latin typeface="Manrope SemiBold" pitchFamily="2" charset="0"/>
               </a:rPr>
@@ -7214,7 +7214,7 @@
             <a:r>
               <a:rPr lang="fr-FR" sz="1600" dirty="0">
                 <a:solidFill>
-                  <a:srgbClr val="A9CCE3"/>
+                  <a:srgbClr val="24577A"/>
                 </a:solidFill>
                 <a:latin typeface="Manrope Medium" pitchFamily="2" charset="0"/>
               </a:rPr>
@@ -7258,7 +7258,7 @@
             </a:pPr>
             <a:endParaRPr lang="fr-FR" sz="1200" dirty="0">
               <a:solidFill>
-                <a:srgbClr val="9CA9B6"/>
+                <a:srgbClr val="5F6B76"/>
               </a:solidFill>
               <a:latin typeface="Manrope" pitchFamily="2" charset="0"/>
             </a:endParaRPr>
@@ -7295,7 +7295,7 @@
           <a:p>
             <a:endParaRPr lang="fr-FR" sz="4800" dirty="0">
               <a:solidFill>
-                <a:srgbClr val="F2F5F8"/>
+                <a:srgbClr val="1D1D1F"/>
               </a:solidFill>
               <a:latin typeface="Manrope SemiBold" pitchFamily="2" charset="0"/>
             </a:endParaRPr>
@@ -7338,7 +7338,7 @@
             <a:r>
               <a:rPr lang="fr-FR" sz="2000" dirty="0">
                 <a:solidFill>
-                  <a:srgbClr val="A9CCE3"/>
+                  <a:srgbClr val="24577A"/>
                 </a:solidFill>
                 <a:latin typeface="Manrope Medium" pitchFamily="2" charset="0"/>
               </a:rPr>
@@ -7383,7 +7383,7 @@
             <a:r>
               <a:rPr lang="fr-FR" sz="1200" dirty="0">
                 <a:solidFill>
-                  <a:srgbClr val="9CA9B6"/>
+                  <a:srgbClr val="5F6B76"/>
                 </a:solidFill>
                 <a:latin typeface="Manrope" pitchFamily="2" charset="0"/>
               </a:rPr>
@@ -7422,7 +7422,7 @@
           <a:p>
             <a:endParaRPr lang="fr-FR" sz="4800" dirty="0">
               <a:solidFill>
-                <a:srgbClr val="F2F5F8"/>
+                <a:srgbClr val="1D1D1F"/>
               </a:solidFill>
               <a:latin typeface="Manrope SemiBold" pitchFamily="2" charset="0"/>
             </a:endParaRPr>
@@ -7465,7 +7465,7 @@
               </a:lnSpc>
               <a:defRPr sz="2000">
                 <a:solidFill>
-                  <a:srgbClr val="A9CCE3"/>
+                  <a:srgbClr val="24577A"/>
                 </a:solidFill>
                 <a:latin typeface="Manrope Medium" pitchFamily="2" charset="0"/>
               </a:defRPr>
@@ -7515,7 +7515,7 @@
             <a:r>
               <a:rPr lang="fr-FR" sz="1200" dirty="0">
                 <a:solidFill>
-                  <a:srgbClr val="9CA9B6"/>
+                  <a:srgbClr val="5F6B76"/>
                 </a:solidFill>
                 <a:latin typeface="Manrope" pitchFamily="2" charset="0"/>
               </a:rPr>
@@ -7548,11 +7548,11 @@
             </a:avLst>
           </a:prstGeom>
           <a:solidFill>
-            <a:srgbClr val="182330"/>
+            <a:srgbClr val="F0F5F8"/>
           </a:solidFill>
           <a:ln w="9525">
             <a:solidFill>
-              <a:srgbClr val="243040"/>
+              <a:srgbClr val="E2E8ED"/>
             </a:solidFill>
           </a:ln>
         </p:spPr>
@@ -7603,7 +7603,7 @@
             <a:avLst/>
           </a:prstGeom>
           <a:solidFill>
-            <a:srgbClr val="A9CCE3"/>
+            <a:srgbClr val="24577A"/>
           </a:solidFill>
           <a:ln w="19050" cap="flat" cmpd="sng" algn="ctr">
             <a:noFill/>
@@ -7687,7 +7687,7 @@
             <a:r>
               <a:rPr lang="fr-FR" sz="1900">
                 <a:solidFill>
-                  <a:srgbClr val="F2F5F8"/>
+                  <a:srgbClr val="1D1D1F"/>
                 </a:solidFill>
                 <a:latin typeface="Manrope Medium" pitchFamily="2" charset="0"/>
               </a:rPr>
@@ -7733,7 +7733,7 @@
             <a:r>
               <a:rPr lang="fr-FR" sz="1350">
                 <a:solidFill>
-                  <a:srgbClr val="9CA9B6"/>
+                  <a:srgbClr val="5F6B76"/>
                 </a:solidFill>
                 <a:latin typeface="Manrope" pitchFamily="2" charset="0"/>
               </a:rPr>
@@ -7779,7 +7779,7 @@
             <a:r>
               <a:rPr lang="fr-FR" sz="1050">
                 <a:solidFill>
-                  <a:srgbClr val="A9CCE3"/>
+                  <a:srgbClr val="24577A"/>
                 </a:solidFill>
                 <a:latin typeface="Manrope" pitchFamily="2" charset="0"/>
               </a:rPr>
@@ -8463,7 +8463,7 @@
     <p:bg>
       <p:bgPr>
         <a:solidFill>
-          <a:srgbClr val="0B1016"/>
+          <a:srgbClr val="F7F9FB"/>
         </a:solidFill>
         <a:effectLst/>
       </p:bgPr>
@@ -8518,7 +8518,7 @@
             <a:r>
               <a:rPr lang="fr-FR" sz="1100" spc="260">
                 <a:solidFill>
-                  <a:srgbClr val="A9CCE3"/>
+                  <a:srgbClr val="24577A"/>
                 </a:solidFill>
                 <a:latin typeface="Manrope SemiBold" pitchFamily="2" charset="0"/>
               </a:rPr>
@@ -8558,7 +8558,7 @@
             <a:r>
               <a:rPr lang="fr-FR" sz="3600" spc="-50">
                 <a:solidFill>
-                  <a:srgbClr val="F2F5F8"/>
+                  <a:srgbClr val="1D1D1F"/>
                 </a:solidFill>
                 <a:latin typeface="Manrope SemiBold" pitchFamily="2" charset="0"/>
               </a:rPr>
@@ -8569,10 +8569,10 @@
                 <a:gradFill flip="none" rotWithShape="1">
                   <a:gsLst>
                     <a:gs pos="0">
-                      <a:srgbClr val="5A93BF"/>
+                      <a:srgbClr val="24577A"/>
                     </a:gs>
                     <a:gs pos="100000">
-                      <a:srgbClr val="A9CCE3"/>
+                      <a:srgbClr val="24577A"/>
                     </a:gs>
                   </a:gsLst>
                   <a:lin ang="0" scaled="1"/>
@@ -8585,7 +8585,7 @@
             <a:r>
               <a:rPr lang="fr-FR" sz="3600" spc="-50">
                 <a:solidFill>
-                  <a:srgbClr val="F2F5F8"/>
+                  <a:srgbClr val="1D1D1F"/>
                 </a:solidFill>
                 <a:latin typeface="Manrope SemiBold" pitchFamily="2" charset="0"/>
               </a:rPr>
@@ -8615,7 +8615,7 @@
             <a:avLst/>
           </a:prstGeom>
           <a:solidFill>
-            <a:srgbClr val="A9CCE3"/>
+            <a:srgbClr val="24577A"/>
           </a:solidFill>
           <a:ln w="19050" cap="flat" cmpd="sng" algn="ctr">
             <a:noFill/>
@@ -8698,7 +8698,7 @@
             <a:r>
               <a:rPr lang="fr-FR" sz="2400">
                 <a:solidFill>
-                  <a:srgbClr val="F2F5F8"/>
+                  <a:srgbClr val="1D1D1F"/>
                 </a:solidFill>
                 <a:latin typeface="Manrope SemiBold" pitchFamily="2" charset="0"/>
               </a:rPr>
@@ -8743,7 +8743,7 @@
             <a:r>
               <a:rPr lang="fr-FR" sz="1400">
                 <a:solidFill>
-                  <a:srgbClr val="9CA9B6"/>
+                  <a:srgbClr val="5F6B76"/>
                 </a:solidFill>
                 <a:latin typeface="Manrope" pitchFamily="2" charset="0"/>
               </a:rPr>
@@ -8773,7 +8773,7 @@
             <a:avLst/>
           </a:prstGeom>
           <a:solidFill>
-            <a:srgbClr val="A9CCE3"/>
+            <a:srgbClr val="24577A"/>
           </a:solidFill>
           <a:ln w="19050" cap="flat" cmpd="sng" algn="ctr">
             <a:noFill/>
@@ -8856,7 +8856,7 @@
             <a:r>
               <a:rPr lang="fr-FR" sz="2400">
                 <a:solidFill>
-                  <a:srgbClr val="F2F5F8"/>
+                  <a:srgbClr val="1D1D1F"/>
                 </a:solidFill>
                 <a:latin typeface="Manrope SemiBold" pitchFamily="2" charset="0"/>
               </a:rPr>
@@ -8901,7 +8901,7 @@
             <a:r>
               <a:rPr lang="fr-FR" sz="1400">
                 <a:solidFill>
-                  <a:srgbClr val="9CA9B6"/>
+                  <a:srgbClr val="5F6B76"/>
                 </a:solidFill>
                 <a:latin typeface="Manrope" pitchFamily="2" charset="0"/>
               </a:rPr>
@@ -8931,7 +8931,7 @@
             <a:avLst/>
           </a:prstGeom>
           <a:solidFill>
-            <a:srgbClr val="A9CCE3"/>
+            <a:srgbClr val="24577A"/>
           </a:solidFill>
           <a:ln w="19050" cap="flat" cmpd="sng" algn="ctr">
             <a:noFill/>
@@ -9014,7 +9014,7 @@
             <a:r>
               <a:rPr lang="fr-FR" sz="2400">
                 <a:solidFill>
-                  <a:srgbClr val="F2F5F8"/>
+                  <a:srgbClr val="1D1D1F"/>
                 </a:solidFill>
                 <a:latin typeface="Manrope SemiBold" pitchFamily="2" charset="0"/>
               </a:rPr>
@@ -9059,7 +9059,7 @@
             <a:r>
               <a:rPr lang="fr-FR" sz="1400">
                 <a:solidFill>
-                  <a:srgbClr val="9CA9B6"/>
+                  <a:srgbClr val="5F6B76"/>
                 </a:solidFill>
                 <a:latin typeface="Manrope" pitchFamily="2" charset="0"/>
               </a:rPr>
@@ -9104,7 +9104,7 @@
             <a:r>
               <a:rPr lang="fr-FR" sz="2000">
                 <a:solidFill>
-                  <a:srgbClr val="A9CCE3"/>
+                  <a:srgbClr val="24577A"/>
                 </a:solidFill>
                 <a:latin typeface="Manrope Medium" pitchFamily="2" charset="0"/>
               </a:rPr>
@@ -9629,7 +9629,7 @@
     <p:bg>
       <p:bgPr>
         <a:solidFill>
-          <a:srgbClr val="0B1016"/>
+          <a:srgbClr val="F7F9FB"/>
         </a:solidFill>
         <a:effectLst/>
       </p:bgPr>
@@ -9684,7 +9684,7 @@
             <a:r>
               <a:rPr lang="fr-FR" sz="1100" spc="260">
                 <a:solidFill>
-                  <a:srgbClr val="A9CCE3"/>
+                  <a:srgbClr val="24577A"/>
                 </a:solidFill>
                 <a:latin typeface="Manrope SemiBold" pitchFamily="2" charset="0"/>
               </a:rPr>
@@ -9724,7 +9724,7 @@
             <a:r>
               <a:rPr lang="fr-FR" sz="3600" spc="-50">
                 <a:solidFill>
-                  <a:srgbClr val="F2F5F8"/>
+                  <a:srgbClr val="1D1D1F"/>
                 </a:solidFill>
                 <a:latin typeface="Manrope SemiBold" pitchFamily="2" charset="0"/>
               </a:rPr>
@@ -9735,10 +9735,10 @@
                 <a:gradFill flip="none" rotWithShape="1">
                   <a:gsLst>
                     <a:gs pos="0">
-                      <a:srgbClr val="5A93BF"/>
+                      <a:srgbClr val="24577A"/>
                     </a:gs>
                     <a:gs pos="100000">
-                      <a:srgbClr val="A9CCE3"/>
+                      <a:srgbClr val="24577A"/>
                     </a:gs>
                   </a:gsLst>
                   <a:lin ang="0" scaled="1"/>
@@ -9751,7 +9751,7 @@
             <a:r>
               <a:rPr lang="fr-FR" sz="3600" spc="-50">
                 <a:solidFill>
-                  <a:srgbClr val="F2F5F8"/>
+                  <a:srgbClr val="1D1D1F"/>
                 </a:solidFill>
                 <a:latin typeface="Manrope SemiBold" pitchFamily="2" charset="0"/>
               </a:rPr>
@@ -9781,7 +9781,7 @@
             <a:avLst/>
           </a:prstGeom>
           <a:solidFill>
-            <a:srgbClr val="A9CCE3"/>
+            <a:srgbClr val="24577A"/>
           </a:solidFill>
           <a:ln w="19050" cap="flat" cmpd="sng" algn="ctr">
             <a:noFill/>
@@ -9864,7 +9864,7 @@
             <a:r>
               <a:rPr lang="fr-FR" sz="1900">
                 <a:solidFill>
-                  <a:srgbClr val="F2F5F8"/>
+                  <a:srgbClr val="1D1D1F"/>
                 </a:solidFill>
                 <a:latin typeface="Manrope Medium" pitchFamily="2" charset="0"/>
               </a:rPr>
@@ -9909,7 +9909,7 @@
             <a:r>
               <a:rPr lang="fr-FR" sz="1350">
                 <a:solidFill>
-                  <a:srgbClr val="9CA9B6"/>
+                  <a:srgbClr val="5F6B76"/>
                 </a:solidFill>
                 <a:latin typeface="Manrope" pitchFamily="2" charset="0"/>
               </a:rPr>
@@ -9939,7 +9939,7 @@
             <a:avLst/>
           </a:prstGeom>
           <a:solidFill>
-            <a:srgbClr val="A9CCE3"/>
+            <a:srgbClr val="24577A"/>
           </a:solidFill>
           <a:ln w="19050" cap="flat" cmpd="sng" algn="ctr">
             <a:noFill/>
@@ -10022,7 +10022,7 @@
             <a:r>
               <a:rPr lang="fr-FR" sz="1900">
                 <a:solidFill>
-                  <a:srgbClr val="F2F5F8"/>
+                  <a:srgbClr val="1D1D1F"/>
                 </a:solidFill>
                 <a:latin typeface="Manrope Medium" pitchFamily="2" charset="0"/>
               </a:rPr>
@@ -10067,7 +10067,7 @@
             <a:r>
               <a:rPr lang="fr-FR" sz="1350">
                 <a:solidFill>
-                  <a:srgbClr val="9CA9B6"/>
+                  <a:srgbClr val="5F6B76"/>
                 </a:solidFill>
                 <a:latin typeface="Manrope" pitchFamily="2" charset="0"/>
               </a:rPr>
@@ -10097,7 +10097,7 @@
             <a:avLst/>
           </a:prstGeom>
           <a:solidFill>
-            <a:srgbClr val="A9CCE3"/>
+            <a:srgbClr val="24577A"/>
           </a:solidFill>
           <a:ln w="19050" cap="flat" cmpd="sng" algn="ctr">
             <a:noFill/>
@@ -10180,7 +10180,7 @@
             <a:r>
               <a:rPr lang="fr-FR" sz="1900">
                 <a:solidFill>
-                  <a:srgbClr val="F2F5F8"/>
+                  <a:srgbClr val="1D1D1F"/>
                 </a:solidFill>
                 <a:latin typeface="Manrope Medium" pitchFamily="2" charset="0"/>
               </a:rPr>
@@ -10225,7 +10225,7 @@
             <a:r>
               <a:rPr lang="fr-FR" sz="1350">
                 <a:solidFill>
-                  <a:srgbClr val="9CA9B6"/>
+                  <a:srgbClr val="5F6B76"/>
                 </a:solidFill>
                 <a:latin typeface="Manrope" pitchFamily="2" charset="0"/>
               </a:rPr>
@@ -10270,7 +10270,7 @@
           </a:prstGeom>
           <a:ln w="9525">
             <a:solidFill>
-              <a:srgbClr val="D0D0D0"/>
+              <a:srgbClr val="E2E8ED"/>
             </a:solidFill>
           </a:ln>
         </p:spPr>
@@ -10755,7 +10755,7 @@
     <p:bg>
       <p:bgPr>
         <a:solidFill>
-          <a:srgbClr val="0B1016"/>
+          <a:srgbClr val="F7F9FB"/>
         </a:solidFill>
         <a:effectLst/>
       </p:bgPr>
@@ -10810,7 +10810,7 @@
             <a:r>
               <a:rPr lang="fr-FR" sz="1100" spc="260">
                 <a:solidFill>
-                  <a:srgbClr val="A9CCE3"/>
+                  <a:srgbClr val="24577A"/>
                 </a:solidFill>
                 <a:latin typeface="Manrope SemiBold" pitchFamily="2" charset="0"/>
               </a:rPr>
@@ -10850,7 +10850,7 @@
             <a:r>
               <a:rPr lang="fr-FR" sz="3600" spc="-50">
                 <a:solidFill>
-                  <a:srgbClr val="F2F5F8"/>
+                  <a:srgbClr val="1D1D1F"/>
                 </a:solidFill>
                 <a:latin typeface="Manrope SemiBold" pitchFamily="2" charset="0"/>
               </a:rPr>
@@ -10861,10 +10861,10 @@
                 <a:gradFill flip="none" rotWithShape="1">
                   <a:gsLst>
                     <a:gs pos="0">
-                      <a:srgbClr val="5A93BF"/>
+                      <a:srgbClr val="24577A"/>
                     </a:gs>
                     <a:gs pos="100000">
-                      <a:srgbClr val="A9CCE3"/>
+                      <a:srgbClr val="24577A"/>
                     </a:gs>
                   </a:gsLst>
                   <a:lin ang="0" scaled="1"/>
@@ -10877,7 +10877,7 @@
             <a:r>
               <a:rPr lang="fr-FR" sz="3600" spc="-50">
                 <a:solidFill>
-                  <a:srgbClr val="F2F5F8"/>
+                  <a:srgbClr val="1D1D1F"/>
                 </a:solidFill>
                 <a:latin typeface="Manrope SemiBold" pitchFamily="2" charset="0"/>
               </a:rPr>
@@ -10922,7 +10922,7 @@
             <a:r>
               <a:rPr lang="fr-FR" sz="1900">
                 <a:solidFill>
-                  <a:srgbClr val="F2F5F8"/>
+                  <a:srgbClr val="1D1D1F"/>
                 </a:solidFill>
                 <a:latin typeface="Manrope Medium" pitchFamily="2" charset="0"/>
               </a:rPr>
@@ -10967,7 +10967,7 @@
             <a:r>
               <a:rPr lang="fr-FR" sz="1350">
                 <a:solidFill>
-                  <a:srgbClr val="9CA9B6"/>
+                  <a:srgbClr val="5F6B76"/>
                 </a:solidFill>
                 <a:latin typeface="Manrope" pitchFamily="2" charset="0"/>
               </a:rPr>
@@ -10997,7 +10997,7 @@
             <a:avLst/>
           </a:prstGeom>
           <a:solidFill>
-            <a:srgbClr val="243040"/>
+            <a:srgbClr val="E2E8ED"/>
           </a:solidFill>
           <a:ln w="19050" cap="flat" cmpd="sng" algn="ctr">
             <a:noFill/>
@@ -11080,7 +11080,7 @@
             <a:r>
               <a:rPr lang="fr-FR" sz="1900">
                 <a:solidFill>
-                  <a:srgbClr val="F2F5F8"/>
+                  <a:srgbClr val="1D1D1F"/>
                 </a:solidFill>
                 <a:latin typeface="Manrope Medium" pitchFamily="2" charset="0"/>
               </a:rPr>
@@ -11125,7 +11125,7 @@
             <a:r>
               <a:rPr lang="fr-FR" sz="1350">
                 <a:solidFill>
-                  <a:srgbClr val="9CA9B6"/>
+                  <a:srgbClr val="5F6B76"/>
                 </a:solidFill>
                 <a:latin typeface="Manrope" pitchFamily="2" charset="0"/>
               </a:rPr>
@@ -11155,7 +11155,7 @@
             <a:avLst/>
           </a:prstGeom>
           <a:solidFill>
-            <a:srgbClr val="243040"/>
+            <a:srgbClr val="E2E8ED"/>
           </a:solidFill>
           <a:ln w="19050" cap="flat" cmpd="sng" algn="ctr">
             <a:noFill/>
@@ -11238,7 +11238,7 @@
             <a:r>
               <a:rPr lang="fr-FR" sz="1900">
                 <a:solidFill>
-                  <a:srgbClr val="F2F5F8"/>
+                  <a:srgbClr val="1D1D1F"/>
                 </a:solidFill>
                 <a:latin typeface="Manrope Medium" pitchFamily="2" charset="0"/>
               </a:rPr>
@@ -11283,7 +11283,7 @@
             <a:r>
               <a:rPr lang="fr-FR" sz="1350">
                 <a:solidFill>
-                  <a:srgbClr val="9CA9B6"/>
+                  <a:srgbClr val="5F6B76"/>
                 </a:solidFill>
                 <a:latin typeface="Manrope" pitchFamily="2" charset="0"/>
               </a:rPr>
@@ -11313,7 +11313,7 @@
             <a:avLst/>
           </a:prstGeom>
           <a:solidFill>
-            <a:srgbClr val="243040"/>
+            <a:srgbClr val="E2E8ED"/>
           </a:solidFill>
           <a:ln w="19050" cap="flat" cmpd="sng" algn="ctr">
             <a:noFill/>
@@ -11382,21 +11382,22 @@
               </a:ext>
             </a:extLst>
           </a:blip>
+          <a:srcRect l="634" t="746"/>
           <a:stretch>
             <a:fillRect/>
           </a:stretch>
         </p:blipFill>
         <p:spPr>
           <a:xfrm>
-            <a:off x="1456306" y="1854200"/>
-            <a:ext cx="4097788" cy="4241800"/>
+            <a:off x="1482290" y="1885846"/>
+            <a:ext cx="4071803" cy="4210153"/>
           </a:xfrm>
           <a:prstGeom prst="rect">
             <a:avLst/>
           </a:prstGeom>
           <a:ln w="9525">
             <a:solidFill>
-              <a:srgbClr val="D0D0D0"/>
+              <a:srgbClr val="E2E8ED"/>
             </a:solidFill>
           </a:ln>
         </p:spPr>
@@ -11881,7 +11882,7 @@
     <p:bg>
       <p:bgPr>
         <a:solidFill>
-          <a:srgbClr val="0B1016"/>
+          <a:srgbClr val="F7F9FB"/>
         </a:solidFill>
         <a:effectLst/>
       </p:bgPr>
@@ -11936,7 +11937,7 @@
             <a:r>
               <a:rPr lang="fr-FR" sz="1100" spc="260">
                 <a:solidFill>
-                  <a:srgbClr val="A9CCE3"/>
+                  <a:srgbClr val="24577A"/>
                 </a:solidFill>
                 <a:latin typeface="Manrope SemiBold" pitchFamily="2" charset="0"/>
               </a:rPr>
@@ -11976,7 +11977,7 @@
             <a:r>
               <a:rPr lang="fr-FR" sz="3600" spc="-50">
                 <a:solidFill>
-                  <a:srgbClr val="F2F5F8"/>
+                  <a:srgbClr val="1D1D1F"/>
                 </a:solidFill>
                 <a:latin typeface="Manrope SemiBold" pitchFamily="2" charset="0"/>
               </a:rPr>
@@ -11987,10 +11988,10 @@
                 <a:gradFill flip="none" rotWithShape="1">
                   <a:gsLst>
                     <a:gs pos="0">
-                      <a:srgbClr val="5A93BF"/>
+                      <a:srgbClr val="24577A"/>
                     </a:gs>
                     <a:gs pos="100000">
-                      <a:srgbClr val="A9CCE3"/>
+                      <a:srgbClr val="24577A"/>
                     </a:gs>
                   </a:gsLst>
                   <a:lin ang="0" scaled="1"/>
@@ -12003,7 +12004,7 @@
             <a:r>
               <a:rPr lang="fr-FR" sz="3600" spc="-50">
                 <a:solidFill>
-                  <a:srgbClr val="F2F5F8"/>
+                  <a:srgbClr val="1D1D1F"/>
                 </a:solidFill>
                 <a:latin typeface="Manrope SemiBold" pitchFamily="2" charset="0"/>
               </a:rPr>
@@ -12035,11 +12036,11 @@
             </a:avLst>
           </a:prstGeom>
           <a:solidFill>
-            <a:srgbClr val="121A23"/>
+            <a:srgbClr val="FFFFFF"/>
           </a:solidFill>
           <a:ln w="9525">
             <a:solidFill>
-              <a:srgbClr val="243040"/>
+              <a:srgbClr val="E2E8ED"/>
             </a:solidFill>
           </a:ln>
         </p:spPr>
@@ -12104,7 +12105,7 @@
             <a:r>
               <a:rPr lang="fr-FR" sz="1000" spc="220">
                 <a:solidFill>
-                  <a:srgbClr val="A9CCE3"/>
+                  <a:srgbClr val="24577A"/>
                 </a:solidFill>
                 <a:latin typeface="Manrope SemiBold" pitchFamily="2" charset="0"/>
               </a:rPr>
@@ -12149,7 +12150,7 @@
             <a:r>
               <a:rPr lang="fr-FR" sz="2100">
                 <a:solidFill>
-                  <a:srgbClr val="F2F5F8"/>
+                  <a:srgbClr val="1D1D1F"/>
                 </a:solidFill>
                 <a:latin typeface="Manrope SemiBold" pitchFamily="2" charset="0"/>
               </a:rPr>
@@ -12179,7 +12180,7 @@
             <a:avLst/>
           </a:prstGeom>
           <a:solidFill>
-            <a:srgbClr val="A9CCE3"/>
+            <a:srgbClr val="24577A"/>
           </a:solidFill>
           <a:ln w="19050" cap="flat" cmpd="sng" algn="ctr">
             <a:noFill/>
@@ -12262,7 +12263,7 @@
             <a:r>
               <a:rPr lang="fr-FR" sz="1250">
                 <a:solidFill>
-                  <a:srgbClr val="9CA9B6"/>
+                  <a:srgbClr val="5F6B76"/>
                 </a:solidFill>
                 <a:latin typeface="Manrope" pitchFamily="2" charset="0"/>
               </a:rPr>
@@ -12292,7 +12293,7 @@
             <a:avLst/>
           </a:prstGeom>
           <a:solidFill>
-            <a:srgbClr val="A9CCE3"/>
+            <a:srgbClr val="24577A"/>
           </a:solidFill>
           <a:ln w="19050" cap="flat" cmpd="sng" algn="ctr">
             <a:noFill/>
@@ -12375,7 +12376,7 @@
             <a:r>
               <a:rPr lang="fr-FR" sz="1250">
                 <a:solidFill>
-                  <a:srgbClr val="9CA9B6"/>
+                  <a:srgbClr val="5F6B76"/>
                 </a:solidFill>
                 <a:latin typeface="Manrope" pitchFamily="2" charset="0"/>
               </a:rPr>
@@ -12405,7 +12406,7 @@
             <a:avLst/>
           </a:prstGeom>
           <a:solidFill>
-            <a:srgbClr val="A9CCE3"/>
+            <a:srgbClr val="24577A"/>
           </a:solidFill>
           <a:ln w="19050" cap="flat" cmpd="sng" algn="ctr">
             <a:noFill/>
@@ -12488,7 +12489,7 @@
             <a:r>
               <a:rPr lang="fr-FR" sz="1250">
                 <a:solidFill>
-                  <a:srgbClr val="9CA9B6"/>
+                  <a:srgbClr val="5F6B76"/>
                 </a:solidFill>
                 <a:latin typeface="Manrope" pitchFamily="2" charset="0"/>
               </a:rPr>
@@ -12520,11 +12521,11 @@
             </a:avLst>
           </a:prstGeom>
           <a:solidFill>
-            <a:srgbClr val="121A23"/>
+            <a:srgbClr val="FFFFFF"/>
           </a:solidFill>
           <a:ln w="9525">
             <a:solidFill>
-              <a:srgbClr val="243040"/>
+              <a:srgbClr val="E2E8ED"/>
             </a:solidFill>
           </a:ln>
         </p:spPr>
@@ -12589,7 +12590,7 @@
             <a:r>
               <a:rPr lang="fr-FR" sz="1000" spc="220">
                 <a:solidFill>
-                  <a:srgbClr val="A9CCE3"/>
+                  <a:srgbClr val="24577A"/>
                 </a:solidFill>
                 <a:latin typeface="Manrope SemiBold" pitchFamily="2" charset="0"/>
               </a:rPr>
@@ -12634,7 +12635,7 @@
             <a:r>
               <a:rPr lang="fr-FR" sz="2100">
                 <a:solidFill>
-                  <a:srgbClr val="F2F5F8"/>
+                  <a:srgbClr val="1D1D1F"/>
                 </a:solidFill>
                 <a:latin typeface="Manrope SemiBold" pitchFamily="2" charset="0"/>
               </a:rPr>
@@ -12664,7 +12665,7 @@
             <a:avLst/>
           </a:prstGeom>
           <a:solidFill>
-            <a:srgbClr val="A9CCE3"/>
+            <a:srgbClr val="24577A"/>
           </a:solidFill>
           <a:ln w="19050" cap="flat" cmpd="sng" algn="ctr">
             <a:noFill/>
@@ -12747,7 +12748,7 @@
             <a:r>
               <a:rPr lang="fr-FR" sz="1250">
                 <a:solidFill>
-                  <a:srgbClr val="9CA9B6"/>
+                  <a:srgbClr val="5F6B76"/>
                 </a:solidFill>
                 <a:latin typeface="Manrope" pitchFamily="2" charset="0"/>
               </a:rPr>
@@ -12777,7 +12778,7 @@
             <a:avLst/>
           </a:prstGeom>
           <a:solidFill>
-            <a:srgbClr val="A9CCE3"/>
+            <a:srgbClr val="24577A"/>
           </a:solidFill>
           <a:ln w="19050" cap="flat" cmpd="sng" algn="ctr">
             <a:noFill/>
@@ -12860,7 +12861,7 @@
             <a:r>
               <a:rPr lang="fr-FR" sz="1250">
                 <a:solidFill>
-                  <a:srgbClr val="9CA9B6"/>
+                  <a:srgbClr val="5F6B76"/>
                 </a:solidFill>
                 <a:latin typeface="Manrope" pitchFamily="2" charset="0"/>
               </a:rPr>
@@ -12890,7 +12891,7 @@
             <a:avLst/>
           </a:prstGeom>
           <a:solidFill>
-            <a:srgbClr val="A9CCE3"/>
+            <a:srgbClr val="24577A"/>
           </a:solidFill>
           <a:ln w="19050" cap="flat" cmpd="sng" algn="ctr">
             <a:noFill/>
@@ -12973,7 +12974,7 @@
             <a:r>
               <a:rPr lang="fr-FR" sz="1250">
                 <a:solidFill>
-                  <a:srgbClr val="9CA9B6"/>
+                  <a:srgbClr val="5F6B76"/>
                 </a:solidFill>
                 <a:latin typeface="Manrope" pitchFamily="2" charset="0"/>
               </a:rPr>
@@ -13005,11 +13006,11 @@
             </a:avLst>
           </a:prstGeom>
           <a:solidFill>
-            <a:srgbClr val="121A23"/>
+            <a:srgbClr val="FFFFFF"/>
           </a:solidFill>
           <a:ln w="9525">
             <a:solidFill>
-              <a:srgbClr val="243040"/>
+              <a:srgbClr val="E2E8ED"/>
             </a:solidFill>
           </a:ln>
         </p:spPr>
@@ -13074,7 +13075,7 @@
             <a:r>
               <a:rPr lang="fr-FR" sz="1000" spc="220">
                 <a:solidFill>
-                  <a:srgbClr val="A9CCE3"/>
+                  <a:srgbClr val="24577A"/>
                 </a:solidFill>
                 <a:latin typeface="Manrope SemiBold" pitchFamily="2" charset="0"/>
               </a:rPr>
@@ -13119,7 +13120,7 @@
             <a:r>
               <a:rPr lang="fr-FR" sz="2100">
                 <a:solidFill>
-                  <a:srgbClr val="F2F5F8"/>
+                  <a:srgbClr val="1D1D1F"/>
                 </a:solidFill>
                 <a:latin typeface="Manrope SemiBold" pitchFamily="2" charset="0"/>
               </a:rPr>
@@ -13149,7 +13150,7 @@
             <a:avLst/>
           </a:prstGeom>
           <a:solidFill>
-            <a:srgbClr val="A9CCE3"/>
+            <a:srgbClr val="24577A"/>
           </a:solidFill>
           <a:ln w="19050" cap="flat" cmpd="sng" algn="ctr">
             <a:noFill/>
@@ -13232,7 +13233,7 @@
             <a:r>
               <a:rPr lang="fr-FR" sz="1250">
                 <a:solidFill>
-                  <a:srgbClr val="9CA9B6"/>
+                  <a:srgbClr val="5F6B76"/>
                 </a:solidFill>
                 <a:latin typeface="Manrope" pitchFamily="2" charset="0"/>
               </a:rPr>
@@ -13262,7 +13263,7 @@
             <a:avLst/>
           </a:prstGeom>
           <a:solidFill>
-            <a:srgbClr val="A9CCE3"/>
+            <a:srgbClr val="24577A"/>
           </a:solidFill>
           <a:ln w="19050" cap="flat" cmpd="sng" algn="ctr">
             <a:noFill/>
@@ -13345,7 +13346,7 @@
             <a:r>
               <a:rPr lang="fr-FR" sz="1250">
                 <a:solidFill>
-                  <a:srgbClr val="9CA9B6"/>
+                  <a:srgbClr val="5F6B76"/>
                 </a:solidFill>
                 <a:latin typeface="Manrope" pitchFamily="2" charset="0"/>
               </a:rPr>
@@ -13375,7 +13376,7 @@
             <a:avLst/>
           </a:prstGeom>
           <a:solidFill>
-            <a:srgbClr val="A9CCE3"/>
+            <a:srgbClr val="24577A"/>
           </a:solidFill>
           <a:ln w="19050" cap="flat" cmpd="sng" algn="ctr">
             <a:noFill/>
@@ -13458,7 +13459,7 @@
             <a:r>
               <a:rPr lang="fr-FR" sz="1250">
                 <a:solidFill>
-                  <a:srgbClr val="9CA9B6"/>
+                  <a:srgbClr val="5F6B76"/>
                 </a:solidFill>
                 <a:latin typeface="Manrope" pitchFamily="2" charset="0"/>
               </a:rPr>
@@ -14595,7 +14596,7 @@
     <p:bg>
       <p:bgPr>
         <a:solidFill>
-          <a:srgbClr val="0B1016"/>
+          <a:srgbClr val="F7F9FB"/>
         </a:solidFill>
         <a:effectLst/>
       </p:bgPr>
@@ -14650,7 +14651,7 @@
             <a:r>
               <a:rPr lang="fr-FR" sz="1100" spc="260">
                 <a:solidFill>
-                  <a:srgbClr val="A9CCE3"/>
+                  <a:srgbClr val="24577A"/>
                 </a:solidFill>
                 <a:latin typeface="Manrope SemiBold" pitchFamily="2" charset="0"/>
               </a:rPr>
@@ -14690,7 +14691,7 @@
             <a:r>
               <a:rPr lang="fr-FR" sz="3600" spc="-50">
                 <a:solidFill>
-                  <a:srgbClr val="F2F5F8"/>
+                  <a:srgbClr val="1D1D1F"/>
                 </a:solidFill>
                 <a:latin typeface="Manrope SemiBold" pitchFamily="2" charset="0"/>
               </a:rPr>
@@ -14701,10 +14702,10 @@
                 <a:gradFill flip="none" rotWithShape="1">
                   <a:gsLst>
                     <a:gs pos="0">
-                      <a:srgbClr val="5A93BF"/>
+                      <a:srgbClr val="24577A"/>
                     </a:gs>
                     <a:gs pos="100000">
-                      <a:srgbClr val="A9CCE3"/>
+                      <a:srgbClr val="24577A"/>
                     </a:gs>
                   </a:gsLst>
                   <a:lin ang="0" scaled="1"/>
@@ -14717,7 +14718,7 @@
             <a:r>
               <a:rPr lang="fr-FR" sz="3600" spc="-50">
                 <a:solidFill>
-                  <a:srgbClr val="F2F5F8"/>
+                  <a:srgbClr val="1D1D1F"/>
                 </a:solidFill>
                 <a:latin typeface="Manrope SemiBold" pitchFamily="2" charset="0"/>
               </a:rPr>
@@ -14757,7 +14758,7 @@
             <a:r>
               <a:rPr lang="fr-FR" sz="7600" spc="-200">
                 <a:solidFill>
-                  <a:srgbClr val="F2F5F8"/>
+                  <a:srgbClr val="1D1D1F"/>
                 </a:solidFill>
                 <a:latin typeface="Manrope SemiBold" pitchFamily="2" charset="0"/>
               </a:rPr>
@@ -14802,7 +14803,7 @@
             <a:r>
               <a:rPr lang="fr-FR">
                 <a:solidFill>
-                  <a:srgbClr val="A9CCE3"/>
+                  <a:srgbClr val="24577A"/>
                 </a:solidFill>
                 <a:latin typeface="Manrope Medium" pitchFamily="2" charset="0"/>
               </a:rPr>
@@ -14847,7 +14848,7 @@
             <a:r>
               <a:rPr lang="en-US" sz="1250">
                 <a:solidFill>
-                  <a:srgbClr val="9CA9B6"/>
+                  <a:srgbClr val="5F6B76"/>
                 </a:solidFill>
                 <a:latin typeface="Manrope" pitchFamily="2" charset="0"/>
               </a:rPr>
@@ -14855,7 +14856,7 @@
             </a:r>
             <a:endParaRPr lang="fr-FR" sz="1250">
               <a:solidFill>
-                <a:srgbClr val="9CA9B6"/>
+                <a:srgbClr val="5F6B76"/>
               </a:solidFill>
               <a:latin typeface="Manrope" pitchFamily="2" charset="0"/>
             </a:endParaRPr>
@@ -14893,7 +14894,7 @@
             <a:r>
               <a:rPr lang="fr-FR" sz="7600" spc="-200">
                 <a:solidFill>
-                  <a:srgbClr val="F2F5F8"/>
+                  <a:srgbClr val="1D1D1F"/>
                 </a:solidFill>
                 <a:latin typeface="Manrope SemiBold" pitchFamily="2" charset="0"/>
               </a:rPr>
@@ -14938,7 +14939,7 @@
             <a:r>
               <a:rPr lang="fr-FR">
                 <a:solidFill>
-                  <a:srgbClr val="A9CCE3"/>
+                  <a:srgbClr val="24577A"/>
                 </a:solidFill>
                 <a:latin typeface="Manrope Medium" pitchFamily="2" charset="0"/>
               </a:rPr>
@@ -14983,7 +14984,7 @@
             <a:r>
               <a:rPr lang="fr-FR" sz="1250">
                 <a:solidFill>
-                  <a:srgbClr val="9CA9B6"/>
+                  <a:srgbClr val="5F6B76"/>
                 </a:solidFill>
                 <a:latin typeface="Manrope" pitchFamily="2" charset="0"/>
               </a:rPr>
@@ -15023,7 +15024,7 @@
             <a:r>
               <a:rPr lang="fr-FR" sz="7600" spc="-200">
                 <a:solidFill>
-                  <a:srgbClr val="F2F5F8"/>
+                  <a:srgbClr val="1D1D1F"/>
                 </a:solidFill>
                 <a:latin typeface="Manrope SemiBold" pitchFamily="2" charset="0"/>
               </a:rPr>
@@ -15068,7 +15069,7 @@
             <a:r>
               <a:rPr lang="fr-FR">
                 <a:solidFill>
-                  <a:srgbClr val="A9CCE3"/>
+                  <a:srgbClr val="24577A"/>
                 </a:solidFill>
                 <a:latin typeface="Manrope Medium" pitchFamily="2" charset="0"/>
               </a:rPr>
@@ -15113,7 +15114,7 @@
             <a:r>
               <a:rPr lang="fr-FR" sz="1250">
                 <a:solidFill>
-                  <a:srgbClr val="9CA9B6"/>
+                  <a:srgbClr val="5F6B76"/>
                 </a:solidFill>
                 <a:latin typeface="Manrope" pitchFamily="2" charset="0"/>
               </a:rPr>
@@ -15153,7 +15154,7 @@
             <a:r>
               <a:rPr lang="fr-FR" sz="7600" spc="-200">
                 <a:solidFill>
-                  <a:srgbClr val="F2F5F8"/>
+                  <a:srgbClr val="1D1D1F"/>
                 </a:solidFill>
                 <a:latin typeface="Manrope SemiBold" pitchFamily="2" charset="0"/>
               </a:rPr>
@@ -15198,7 +15199,7 @@
             <a:r>
               <a:rPr lang="fr-FR">
                 <a:solidFill>
-                  <a:srgbClr val="A9CCE3"/>
+                  <a:srgbClr val="24577A"/>
                 </a:solidFill>
                 <a:latin typeface="Manrope Medium" pitchFamily="2" charset="0"/>
               </a:rPr>
@@ -15243,7 +15244,7 @@
             <a:r>
               <a:rPr lang="fr-FR" sz="1250">
                 <a:solidFill>
-                  <a:srgbClr val="9CA9B6"/>
+                  <a:srgbClr val="5F6B76"/>
                 </a:solidFill>
                 <a:latin typeface="Manrope" pitchFamily="2" charset="0"/>
               </a:rPr>
@@ -15273,7 +15274,7 @@
             <a:avLst/>
           </a:prstGeom>
           <a:solidFill>
-            <a:srgbClr val="243040"/>
+            <a:srgbClr val="E2E8ED"/>
           </a:solidFill>
           <a:ln w="19050" cap="flat" cmpd="sng" algn="ctr">
             <a:noFill/>
@@ -15356,7 +15357,7 @@
             <a:r>
               <a:rPr lang="fr-FR" sz="1400">
                 <a:solidFill>
-                  <a:srgbClr val="9CA9B6"/>
+                  <a:srgbClr val="5F6B76"/>
                 </a:solidFill>
                 <a:latin typeface="Manrope" pitchFamily="2" charset="0"/>
               </a:rPr>
@@ -16025,7 +16026,7 @@
     <p:bg>
       <p:bgPr>
         <a:solidFill>
-          <a:srgbClr val="0B1016"/>
+          <a:srgbClr val="F7F9FB"/>
         </a:solidFill>
         <a:effectLst/>
       </p:bgPr>
@@ -16080,7 +16081,7 @@
             <a:r>
               <a:rPr lang="fr-FR" sz="1100" spc="260">
                 <a:solidFill>
-                  <a:srgbClr val="A9CCE3"/>
+                  <a:srgbClr val="24577A"/>
                 </a:solidFill>
                 <a:latin typeface="Manrope SemiBold" pitchFamily="2" charset="0"/>
               </a:rPr>
@@ -16120,7 +16121,7 @@
             <a:r>
               <a:rPr lang="fr-FR" sz="3600" spc="-50">
                 <a:solidFill>
-                  <a:srgbClr val="F2F5F8"/>
+                  <a:srgbClr val="1D1D1F"/>
                 </a:solidFill>
                 <a:latin typeface="Manrope SemiBold" pitchFamily="2" charset="0"/>
               </a:rPr>
@@ -16131,10 +16132,10 @@
                 <a:gradFill flip="none" rotWithShape="1">
                   <a:gsLst>
                     <a:gs pos="0">
-                      <a:srgbClr val="5A93BF"/>
+                      <a:srgbClr val="24577A"/>
                     </a:gs>
                     <a:gs pos="100000">
-                      <a:srgbClr val="A9CCE3"/>
+                      <a:srgbClr val="24577A"/>
                     </a:gs>
                   </a:gsLst>
                   <a:lin ang="0" scaled="1"/>
@@ -16147,7 +16148,7 @@
             <a:r>
               <a:rPr lang="fr-FR" sz="3600" spc="-50">
                 <a:solidFill>
-                  <a:srgbClr val="F2F5F8"/>
+                  <a:srgbClr val="1D1D1F"/>
                 </a:solidFill>
                 <a:latin typeface="Manrope SemiBold" pitchFamily="2" charset="0"/>
               </a:rPr>
@@ -16179,11 +16180,11 @@
             </a:avLst>
           </a:prstGeom>
           <a:solidFill>
-            <a:srgbClr val="121A23"/>
+            <a:srgbClr val="FFFFFF"/>
           </a:solidFill>
           <a:ln w="9525">
             <a:solidFill>
-              <a:srgbClr val="243040"/>
+              <a:srgbClr val="E2E8ED"/>
             </a:solidFill>
           </a:ln>
         </p:spPr>
@@ -16248,7 +16249,7 @@
             <a:r>
               <a:rPr lang="fr-FR" sz="1000" spc="220">
                 <a:solidFill>
-                  <a:srgbClr val="A9CCE3"/>
+                  <a:srgbClr val="24577A"/>
                 </a:solidFill>
                 <a:latin typeface="Manrope SemiBold" pitchFamily="2" charset="0"/>
               </a:rPr>
@@ -16293,7 +16294,7 @@
             <a:r>
               <a:rPr lang="fr-FR" sz="2400">
                 <a:solidFill>
-                  <a:srgbClr val="F2F5F8"/>
+                  <a:srgbClr val="1D1D1F"/>
                 </a:solidFill>
                 <a:latin typeface="Manrope SemiBold" pitchFamily="2" charset="0"/>
               </a:rPr>
@@ -16338,7 +16339,7 @@
             <a:r>
               <a:rPr lang="fr-FR" sz="1250">
                 <a:solidFill>
-                  <a:srgbClr val="9CA9B6"/>
+                  <a:srgbClr val="5F6B76"/>
                 </a:solidFill>
                 <a:latin typeface="Manrope" pitchFamily="2" charset="0"/>
               </a:rPr>
@@ -16369,7 +16370,7 @@
           </a:prstGeom>
           <a:ln w="15875">
             <a:solidFill>
-              <a:srgbClr val="9CA9B6"/>
+              <a:srgbClr val="5F6B76"/>
             </a:solidFill>
             <a:tailEnd type="triangle" w="med" len="med"/>
           </a:ln>
@@ -16412,11 +16413,11 @@
             </a:avLst>
           </a:prstGeom>
           <a:solidFill>
-            <a:srgbClr val="121A23"/>
+            <a:srgbClr val="FFFFFF"/>
           </a:solidFill>
           <a:ln w="9525">
             <a:solidFill>
-              <a:srgbClr val="243040"/>
+              <a:srgbClr val="E2E8ED"/>
             </a:solidFill>
           </a:ln>
         </p:spPr>
@@ -16481,7 +16482,7 @@
             <a:r>
               <a:rPr lang="fr-FR" sz="1000" spc="220">
                 <a:solidFill>
-                  <a:srgbClr val="A9CCE3"/>
+                  <a:srgbClr val="24577A"/>
                 </a:solidFill>
                 <a:latin typeface="Manrope SemiBold" pitchFamily="2" charset="0"/>
               </a:rPr>
@@ -16526,7 +16527,7 @@
             <a:r>
               <a:rPr lang="fr-FR" sz="2400">
                 <a:solidFill>
-                  <a:srgbClr val="F2F5F8"/>
+                  <a:srgbClr val="1D1D1F"/>
                 </a:solidFill>
                 <a:latin typeface="Manrope SemiBold" pitchFamily="2" charset="0"/>
               </a:rPr>
@@ -16571,7 +16572,7 @@
             <a:r>
               <a:rPr lang="fr-FR" sz="1250">
                 <a:solidFill>
-                  <a:srgbClr val="9CA9B6"/>
+                  <a:srgbClr val="5F6B76"/>
                 </a:solidFill>
                 <a:latin typeface="Manrope" pitchFamily="2" charset="0"/>
               </a:rPr>
@@ -16602,7 +16603,7 @@
           </a:prstGeom>
           <a:ln w="15875">
             <a:solidFill>
-              <a:srgbClr val="9CA9B6"/>
+              <a:srgbClr val="5F6B76"/>
             </a:solidFill>
             <a:tailEnd type="triangle" w="med" len="med"/>
           </a:ln>
@@ -16645,11 +16646,11 @@
             </a:avLst>
           </a:prstGeom>
           <a:solidFill>
-            <a:srgbClr val="121A23"/>
+            <a:srgbClr val="FFFFFF"/>
           </a:solidFill>
           <a:ln w="9525">
             <a:solidFill>
-              <a:srgbClr val="243040"/>
+              <a:srgbClr val="E2E8ED"/>
             </a:solidFill>
           </a:ln>
         </p:spPr>
@@ -16714,7 +16715,7 @@
             <a:r>
               <a:rPr lang="fr-FR" sz="1000" spc="220">
                 <a:solidFill>
-                  <a:srgbClr val="A9CCE3"/>
+                  <a:srgbClr val="24577A"/>
                 </a:solidFill>
                 <a:latin typeface="Manrope SemiBold" pitchFamily="2" charset="0"/>
               </a:rPr>
@@ -16759,7 +16760,7 @@
             <a:r>
               <a:rPr lang="fr-FR" sz="2400">
                 <a:solidFill>
-                  <a:srgbClr val="F2F5F8"/>
+                  <a:srgbClr val="1D1D1F"/>
                 </a:solidFill>
                 <a:latin typeface="Manrope SemiBold" pitchFamily="2" charset="0"/>
               </a:rPr>
@@ -16804,7 +16805,7 @@
             <a:r>
               <a:rPr lang="fr-FR" sz="1250">
                 <a:solidFill>
-                  <a:srgbClr val="9CA9B6"/>
+                  <a:srgbClr val="5F6B76"/>
                 </a:solidFill>
                 <a:latin typeface="Manrope" pitchFamily="2" charset="0"/>
               </a:rPr>
@@ -16836,7 +16837,7 @@
             </a:avLst>
           </a:prstGeom>
           <a:solidFill>
-            <a:srgbClr val="182330"/>
+            <a:srgbClr val="F0F5F8"/>
           </a:solidFill>
           <a:ln w="19050" cap="flat" cmpd="sng" algn="ctr">
             <a:noFill/>
@@ -16904,7 +16905,7 @@
             <a:avLst/>
           </a:prstGeom>
           <a:solidFill>
-            <a:srgbClr val="A9CCE3"/>
+            <a:srgbClr val="24577A"/>
           </a:solidFill>
           <a:ln w="19050" cap="flat" cmpd="sng" algn="ctr">
             <a:noFill/>
@@ -16987,7 +16988,7 @@
             <a:r>
               <a:rPr lang="fr-FR">
                 <a:solidFill>
-                  <a:srgbClr val="F2F5F8"/>
+                  <a:srgbClr val="1D1D1F"/>
                 </a:solidFill>
                 <a:latin typeface="Manrope Medium" pitchFamily="2" charset="0"/>
               </a:rPr>
@@ -17032,7 +17033,7 @@
             <a:r>
               <a:rPr lang="fr-FR" sz="1350">
                 <a:solidFill>
-                  <a:srgbClr val="9CA9B6"/>
+                  <a:srgbClr val="5F6B76"/>
                 </a:solidFill>
                 <a:latin typeface="Manrope" pitchFamily="2" charset="0"/>
               </a:rPr>
@@ -17843,7 +17844,7 @@
     <p:bg>
       <p:bgPr>
         <a:solidFill>
-          <a:srgbClr val="0B1016"/>
+          <a:srgbClr val="F7F9FB"/>
         </a:solidFill>
         <a:effectLst/>
       </p:bgPr>
@@ -17898,7 +17899,7 @@
             <a:r>
               <a:rPr lang="fr-FR" sz="1100" spc="260">
                 <a:solidFill>
-                  <a:srgbClr val="A9CCE3"/>
+                  <a:srgbClr val="24577A"/>
                 </a:solidFill>
                 <a:latin typeface="Manrope SemiBold" pitchFamily="2" charset="0"/>
               </a:rPr>
@@ -17938,7 +17939,7 @@
             <a:r>
               <a:rPr lang="fr-FR" sz="3600" spc="-50">
                 <a:solidFill>
-                  <a:srgbClr val="F2F5F8"/>
+                  <a:srgbClr val="1D1D1F"/>
                 </a:solidFill>
                 <a:latin typeface="Manrope SemiBold" pitchFamily="2" charset="0"/>
               </a:rPr>
@@ -17949,10 +17950,10 @@
                 <a:gradFill flip="none" rotWithShape="1">
                   <a:gsLst>
                     <a:gs pos="0">
-                      <a:srgbClr val="5A93BF"/>
+                      <a:srgbClr val="24577A"/>
                     </a:gs>
                     <a:gs pos="100000">
-                      <a:srgbClr val="A9CCE3"/>
+                      <a:srgbClr val="24577A"/>
                     </a:gs>
                   </a:gsLst>
                   <a:lin ang="0" scaled="1"/>
@@ -17965,7 +17966,7 @@
             <a:r>
               <a:rPr lang="fr-FR" sz="3600" spc="-50">
                 <a:solidFill>
-                  <a:srgbClr val="F2F5F8"/>
+                  <a:srgbClr val="1D1D1F"/>
                 </a:solidFill>
                 <a:latin typeface="Manrope SemiBold" pitchFamily="2" charset="0"/>
               </a:rPr>
@@ -17997,11 +17998,11 @@
             </a:avLst>
           </a:prstGeom>
           <a:solidFill>
-            <a:srgbClr val="121A23"/>
+            <a:srgbClr val="FFFFFF"/>
           </a:solidFill>
           <a:ln w="9525">
             <a:solidFill>
-              <a:srgbClr val="243040"/>
+              <a:srgbClr val="E2E8ED"/>
             </a:solidFill>
           </a:ln>
         </p:spPr>
@@ -18066,7 +18067,7 @@
             <a:r>
               <a:rPr lang="fr-FR" sz="1200">
                 <a:solidFill>
-                  <a:srgbClr val="A9CCE3"/>
+                  <a:srgbClr val="24577A"/>
                 </a:solidFill>
                 <a:latin typeface="Manrope SemiBold" pitchFamily="2" charset="0"/>
               </a:rPr>
@@ -18111,7 +18112,7 @@
             <a:r>
               <a:rPr lang="fr-FR" sz="1550">
                 <a:solidFill>
-                  <a:srgbClr val="F2F5F8"/>
+                  <a:srgbClr val="1D1D1F"/>
                 </a:solidFill>
                 <a:latin typeface="Manrope Medium" pitchFamily="2" charset="0"/>
               </a:rPr>
@@ -18156,7 +18157,7 @@
             <a:r>
               <a:rPr lang="fr-FR" sz="1150">
                 <a:solidFill>
-                  <a:srgbClr val="9CA9B6"/>
+                  <a:srgbClr val="5F6B76"/>
                 </a:solidFill>
                 <a:latin typeface="Manrope" pitchFamily="2" charset="0"/>
               </a:rPr>
@@ -18187,7 +18188,7 @@
           </a:prstGeom>
           <a:ln w="15875">
             <a:solidFill>
-              <a:srgbClr val="9CA9B6"/>
+              <a:srgbClr val="5F6B76"/>
             </a:solidFill>
             <a:tailEnd type="triangle" w="med" len="med"/>
           </a:ln>
@@ -18230,11 +18231,11 @@
             </a:avLst>
           </a:prstGeom>
           <a:solidFill>
-            <a:srgbClr val="121A23"/>
+            <a:srgbClr val="FFFFFF"/>
           </a:solidFill>
           <a:ln w="9525">
             <a:solidFill>
-              <a:srgbClr val="243040"/>
+              <a:srgbClr val="E2E8ED"/>
             </a:solidFill>
           </a:ln>
         </p:spPr>
@@ -18299,7 +18300,7 @@
             <a:r>
               <a:rPr lang="fr-FR" sz="1200">
                 <a:solidFill>
-                  <a:srgbClr val="A9CCE3"/>
+                  <a:srgbClr val="24577A"/>
                 </a:solidFill>
                 <a:latin typeface="Manrope SemiBold" pitchFamily="2" charset="0"/>
               </a:rPr>
@@ -18344,7 +18345,7 @@
             <a:r>
               <a:rPr lang="fr-FR" sz="1550">
                 <a:solidFill>
-                  <a:srgbClr val="F2F5F8"/>
+                  <a:srgbClr val="1D1D1F"/>
                 </a:solidFill>
                 <a:latin typeface="Manrope Medium" pitchFamily="2" charset="0"/>
               </a:rPr>
@@ -18389,7 +18390,7 @@
             <a:r>
               <a:rPr lang="fr-FR" sz="1150">
                 <a:solidFill>
-                  <a:srgbClr val="9CA9B6"/>
+                  <a:srgbClr val="5F6B76"/>
                 </a:solidFill>
                 <a:latin typeface="Manrope" pitchFamily="2" charset="0"/>
               </a:rPr>
@@ -18420,7 +18421,7 @@
           </a:prstGeom>
           <a:ln w="15875">
             <a:solidFill>
-              <a:srgbClr val="9CA9B6"/>
+              <a:srgbClr val="5F6B76"/>
             </a:solidFill>
             <a:tailEnd type="triangle" w="med" len="med"/>
           </a:ln>
@@ -18463,11 +18464,11 @@
             </a:avLst>
           </a:prstGeom>
           <a:solidFill>
-            <a:srgbClr val="121A23"/>
+            <a:srgbClr val="FFFFFF"/>
           </a:solidFill>
           <a:ln w="9525">
             <a:solidFill>
-              <a:srgbClr val="243040"/>
+              <a:srgbClr val="E2E8ED"/>
             </a:solidFill>
           </a:ln>
         </p:spPr>
@@ -18532,7 +18533,7 @@
             <a:r>
               <a:rPr lang="fr-FR" sz="1200">
                 <a:solidFill>
-                  <a:srgbClr val="A9CCE3"/>
+                  <a:srgbClr val="24577A"/>
                 </a:solidFill>
                 <a:latin typeface="Manrope SemiBold" pitchFamily="2" charset="0"/>
               </a:rPr>
@@ -18577,7 +18578,7 @@
             <a:r>
               <a:rPr lang="fr-FR" sz="1550">
                 <a:solidFill>
-                  <a:srgbClr val="F2F5F8"/>
+                  <a:srgbClr val="1D1D1F"/>
                 </a:solidFill>
                 <a:latin typeface="Manrope Medium" pitchFamily="2" charset="0"/>
               </a:rPr>
@@ -18622,7 +18623,7 @@
             <a:r>
               <a:rPr lang="fr-FR" sz="1150">
                 <a:solidFill>
-                  <a:srgbClr val="9CA9B6"/>
+                  <a:srgbClr val="5F6B76"/>
                 </a:solidFill>
                 <a:latin typeface="Manrope" pitchFamily="2" charset="0"/>
               </a:rPr>
@@ -18653,7 +18654,7 @@
           </a:prstGeom>
           <a:ln w="15875">
             <a:solidFill>
-              <a:srgbClr val="9CA9B6"/>
+              <a:srgbClr val="5F6B76"/>
             </a:solidFill>
             <a:tailEnd type="triangle" w="med" len="med"/>
           </a:ln>
@@ -18696,11 +18697,11 @@
             </a:avLst>
           </a:prstGeom>
           <a:solidFill>
-            <a:srgbClr val="121A23"/>
+            <a:srgbClr val="FFFFFF"/>
           </a:solidFill>
           <a:ln w="9525">
             <a:solidFill>
-              <a:srgbClr val="243040"/>
+              <a:srgbClr val="E2E8ED"/>
             </a:solidFill>
           </a:ln>
         </p:spPr>
@@ -18765,7 +18766,7 @@
             <a:r>
               <a:rPr lang="fr-FR" sz="1200">
                 <a:solidFill>
-                  <a:srgbClr val="A9CCE3"/>
+                  <a:srgbClr val="24577A"/>
                 </a:solidFill>
                 <a:latin typeface="Manrope SemiBold" pitchFamily="2" charset="0"/>
               </a:rPr>
@@ -18810,7 +18811,7 @@
             <a:r>
               <a:rPr lang="fr-FR" sz="1550">
                 <a:solidFill>
-                  <a:srgbClr val="F2F5F8"/>
+                  <a:srgbClr val="1D1D1F"/>
                 </a:solidFill>
                 <a:latin typeface="Manrope Medium" pitchFamily="2" charset="0"/>
               </a:rPr>
@@ -18855,7 +18856,7 @@
             <a:r>
               <a:rPr lang="fr-FR" sz="1150">
                 <a:solidFill>
-                  <a:srgbClr val="9CA9B6"/>
+                  <a:srgbClr val="5F6B76"/>
                 </a:solidFill>
                 <a:latin typeface="Manrope" pitchFamily="2" charset="0"/>
               </a:rPr>
@@ -18885,7 +18886,7 @@
             <a:avLst/>
           </a:prstGeom>
           <a:solidFill>
-            <a:srgbClr val="A9CCE3"/>
+            <a:srgbClr val="24577A"/>
           </a:solidFill>
           <a:ln w="19050" cap="flat" cmpd="sng" algn="ctr">
             <a:noFill/>
@@ -18968,7 +18969,7 @@
             <a:r>
               <a:rPr lang="fr-FR" sz="1500">
                 <a:solidFill>
-                  <a:srgbClr val="F2F5F8"/>
+                  <a:srgbClr val="1D1D1F"/>
                 </a:solidFill>
                 <a:latin typeface="Manrope Medium" pitchFamily="2" charset="0"/>
               </a:rPr>
@@ -19013,7 +19014,7 @@
             <a:r>
               <a:rPr lang="fr-FR" sz="1200">
                 <a:solidFill>
-                  <a:srgbClr val="9CA9B6"/>
+                  <a:srgbClr val="5F6B76"/>
                 </a:solidFill>
                 <a:latin typeface="Manrope" pitchFamily="2" charset="0"/>
               </a:rPr>
@@ -19043,7 +19044,7 @@
             <a:avLst/>
           </a:prstGeom>
           <a:solidFill>
-            <a:srgbClr val="A9CCE3"/>
+            <a:srgbClr val="24577A"/>
           </a:solidFill>
           <a:ln w="19050" cap="flat" cmpd="sng" algn="ctr">
             <a:noFill/>
@@ -19126,7 +19127,7 @@
             <a:r>
               <a:rPr lang="fr-FR" sz="1500">
                 <a:solidFill>
-                  <a:srgbClr val="F2F5F8"/>
+                  <a:srgbClr val="1D1D1F"/>
                 </a:solidFill>
                 <a:latin typeface="Manrope Medium" pitchFamily="2" charset="0"/>
               </a:rPr>
@@ -19171,7 +19172,7 @@
             <a:r>
               <a:rPr lang="fr-FR" sz="1200">
                 <a:solidFill>
-                  <a:srgbClr val="9CA9B6"/>
+                  <a:srgbClr val="5F6B76"/>
                 </a:solidFill>
                 <a:latin typeface="Manrope" pitchFamily="2" charset="0"/>
               </a:rPr>
@@ -19201,7 +19202,7 @@
             <a:avLst/>
           </a:prstGeom>
           <a:solidFill>
-            <a:srgbClr val="A9CCE3"/>
+            <a:srgbClr val="24577A"/>
           </a:solidFill>
           <a:ln w="19050" cap="flat" cmpd="sng" algn="ctr">
             <a:noFill/>
@@ -19284,7 +19285,7 @@
             <a:r>
               <a:rPr lang="fr-FR" sz="1500">
                 <a:solidFill>
-                  <a:srgbClr val="F2F5F8"/>
+                  <a:srgbClr val="1D1D1F"/>
                 </a:solidFill>
                 <a:latin typeface="Manrope Medium" pitchFamily="2" charset="0"/>
               </a:rPr>
@@ -19329,7 +19330,7 @@
             <a:r>
               <a:rPr lang="fr-FR" sz="1200">
                 <a:solidFill>
-                  <a:srgbClr val="9CA9B6"/>
+                  <a:srgbClr val="5F6B76"/>
                 </a:solidFill>
                 <a:latin typeface="Manrope" pitchFamily="2" charset="0"/>
               </a:rPr>
@@ -19359,7 +19360,7 @@
             <a:avLst/>
           </a:prstGeom>
           <a:solidFill>
-            <a:srgbClr val="A9CCE3"/>
+            <a:srgbClr val="24577A"/>
           </a:solidFill>
           <a:ln w="19050" cap="flat" cmpd="sng" algn="ctr">
             <a:noFill/>
@@ -19442,7 +19443,7 @@
             <a:r>
               <a:rPr lang="fr-FR" sz="1500">
                 <a:solidFill>
-                  <a:srgbClr val="F2F5F8"/>
+                  <a:srgbClr val="1D1D1F"/>
                 </a:solidFill>
                 <a:latin typeface="Manrope Medium" pitchFamily="2" charset="0"/>
               </a:rPr>
@@ -19487,7 +19488,7 @@
             <a:r>
               <a:rPr lang="fr-FR" sz="1200">
                 <a:solidFill>
-                  <a:srgbClr val="9CA9B6"/>
+                  <a:srgbClr val="5F6B76"/>
                 </a:solidFill>
                 <a:latin typeface="Manrope" pitchFamily="2" charset="0"/>
               </a:rPr>
@@ -20765,7 +20766,7 @@
     <p:bg>
       <p:bgPr>
         <a:solidFill>
-          <a:srgbClr val="0B1016"/>
+          <a:srgbClr val="F7F9FB"/>
         </a:solidFill>
         <a:effectLst/>
       </p:bgPr>
@@ -20820,7 +20821,7 @@
             <a:r>
               <a:rPr lang="fr-FR" sz="1100" spc="260">
                 <a:solidFill>
-                  <a:srgbClr val="A9CCE3"/>
+                  <a:srgbClr val="24577A"/>
                 </a:solidFill>
                 <a:latin typeface="Manrope SemiBold" pitchFamily="2" charset="0"/>
               </a:rPr>
@@ -20860,7 +20861,7 @@
             <a:r>
               <a:rPr lang="fr-FR" sz="3200" spc="-50" dirty="0">
                 <a:solidFill>
-                  <a:srgbClr val="F2F5F8"/>
+                  <a:srgbClr val="1D1D1F"/>
                 </a:solidFill>
                 <a:latin typeface="Manrope SemiBold" pitchFamily="2" charset="0"/>
               </a:rPr>
@@ -20871,10 +20872,10 @@
                 <a:gradFill flip="none" rotWithShape="1">
                   <a:gsLst>
                     <a:gs pos="0">
-                      <a:srgbClr val="5A93BF"/>
+                      <a:srgbClr val="24577A"/>
                     </a:gs>
                     <a:gs pos="100000">
-                      <a:srgbClr val="A9CCE3"/>
+                      <a:srgbClr val="24577A"/>
                     </a:gs>
                   </a:gsLst>
                   <a:lin ang="0" scaled="1"/>
@@ -20887,7 +20888,7 @@
             <a:r>
               <a:rPr lang="fr-FR" sz="3200" spc="-50" dirty="0">
                 <a:solidFill>
-                  <a:srgbClr val="F2F5F8"/>
+                  <a:srgbClr val="1D1D1F"/>
                 </a:solidFill>
                 <a:latin typeface="Manrope SemiBold" pitchFamily="2" charset="0"/>
               </a:rPr>
@@ -20919,11 +20920,11 @@
             </a:avLst>
           </a:prstGeom>
           <a:solidFill>
-            <a:srgbClr val="121A23"/>
+            <a:srgbClr val="FFFFFF"/>
           </a:solidFill>
           <a:ln w="9525">
             <a:solidFill>
-              <a:srgbClr val="243040"/>
+              <a:srgbClr val="E2E8ED"/>
             </a:solidFill>
           </a:ln>
         </p:spPr>
@@ -20988,7 +20989,7 @@
             <a:r>
               <a:rPr lang="fr-FR" sz="1900">
                 <a:solidFill>
-                  <a:srgbClr val="F2F5F8"/>
+                  <a:srgbClr val="1D1D1F"/>
                 </a:solidFill>
                 <a:latin typeface="Manrope SemiBold" pitchFamily="2" charset="0"/>
               </a:rPr>
@@ -21033,7 +21034,7 @@
             <a:r>
               <a:rPr lang="fr-FR" sz="1300">
                 <a:solidFill>
-                  <a:srgbClr val="A9CCE3"/>
+                  <a:srgbClr val="24577A"/>
                 </a:solidFill>
                 <a:latin typeface="Manrope Medium" pitchFamily="2" charset="0"/>
               </a:rPr>
@@ -21078,7 +21079,7 @@
             <a:r>
               <a:rPr lang="fr-FR" sz="1250">
                 <a:solidFill>
-                  <a:srgbClr val="9CA9B6"/>
+                  <a:srgbClr val="5F6B76"/>
                 </a:solidFill>
                 <a:latin typeface="Manrope" pitchFamily="2" charset="0"/>
               </a:rPr>
@@ -21110,11 +21111,11 @@
             </a:avLst>
           </a:prstGeom>
           <a:solidFill>
-            <a:srgbClr val="121A23"/>
+            <a:srgbClr val="FFFFFF"/>
           </a:solidFill>
           <a:ln w="9525">
             <a:solidFill>
-              <a:srgbClr val="243040"/>
+              <a:srgbClr val="E2E8ED"/>
             </a:solidFill>
           </a:ln>
         </p:spPr>
@@ -21179,7 +21180,7 @@
             <a:r>
               <a:rPr lang="fr-FR" sz="1900">
                 <a:solidFill>
-                  <a:srgbClr val="F2F5F8"/>
+                  <a:srgbClr val="1D1D1F"/>
                 </a:solidFill>
                 <a:latin typeface="Manrope SemiBold" pitchFamily="2" charset="0"/>
               </a:rPr>
@@ -21224,7 +21225,7 @@
             <a:r>
               <a:rPr lang="fr-FR" sz="1300">
                 <a:solidFill>
-                  <a:srgbClr val="A9CCE3"/>
+                  <a:srgbClr val="24577A"/>
                 </a:solidFill>
                 <a:latin typeface="Manrope Medium" pitchFamily="2" charset="0"/>
               </a:rPr>
@@ -21269,7 +21270,7 @@
             <a:r>
               <a:rPr lang="fr-FR" sz="1250">
                 <a:solidFill>
-                  <a:srgbClr val="9CA9B6"/>
+                  <a:srgbClr val="5F6B76"/>
                 </a:solidFill>
                 <a:latin typeface="Manrope" pitchFamily="2" charset="0"/>
               </a:rPr>
@@ -21301,11 +21302,11 @@
             </a:avLst>
           </a:prstGeom>
           <a:solidFill>
-            <a:srgbClr val="121A23"/>
+            <a:srgbClr val="FFFFFF"/>
           </a:solidFill>
           <a:ln w="9525">
             <a:solidFill>
-              <a:srgbClr val="243040"/>
+              <a:srgbClr val="E2E8ED"/>
             </a:solidFill>
           </a:ln>
         </p:spPr>
@@ -21370,7 +21371,7 @@
             <a:r>
               <a:rPr lang="fr-FR" sz="1900">
                 <a:solidFill>
-                  <a:srgbClr val="F2F5F8"/>
+                  <a:srgbClr val="1D1D1F"/>
                 </a:solidFill>
                 <a:latin typeface="Manrope SemiBold" pitchFamily="2" charset="0"/>
               </a:rPr>
@@ -21415,7 +21416,7 @@
             <a:r>
               <a:rPr lang="fr-FR" sz="1300">
                 <a:solidFill>
-                  <a:srgbClr val="A9CCE3"/>
+                  <a:srgbClr val="24577A"/>
                 </a:solidFill>
                 <a:latin typeface="Manrope Medium" pitchFamily="2" charset="0"/>
               </a:rPr>
@@ -21460,7 +21461,7 @@
             <a:r>
               <a:rPr lang="fr-FR" sz="1250">
                 <a:solidFill>
-                  <a:srgbClr val="9CA9B6"/>
+                  <a:srgbClr val="5F6B76"/>
                 </a:solidFill>
                 <a:latin typeface="Manrope" pitchFamily="2" charset="0"/>
               </a:rPr>
@@ -21505,7 +21506,7 @@
             <a:r>
               <a:rPr lang="fr-FR" sz="1700">
                 <a:solidFill>
-                  <a:srgbClr val="F2F5F8"/>
+                  <a:srgbClr val="1D1D1F"/>
                 </a:solidFill>
                 <a:latin typeface="Manrope Medium" pitchFamily="2" charset="0"/>
               </a:rPr>
@@ -21550,7 +21551,7 @@
             <a:r>
               <a:rPr lang="fr-FR" sz="1300">
                 <a:solidFill>
-                  <a:srgbClr val="9CA9B6"/>
+                  <a:srgbClr val="5F6B76"/>
                 </a:solidFill>
                 <a:latin typeface="Manrope" pitchFamily="2" charset="0"/>
               </a:rPr>
@@ -21581,7 +21582,7 @@
           </a:prstGeom>
           <a:ln w="15875">
             <a:solidFill>
-              <a:srgbClr val="9CA9B6"/>
+              <a:srgbClr val="5F6B76"/>
             </a:solidFill>
             <a:tailEnd type="triangle" w="med" len="med"/>
           </a:ln>
@@ -21637,7 +21638,7 @@
             <a:r>
               <a:rPr lang="fr-FR" sz="1700">
                 <a:solidFill>
-                  <a:srgbClr val="F2F5F8"/>
+                  <a:srgbClr val="1D1D1F"/>
                 </a:solidFill>
                 <a:latin typeface="Manrope Medium" pitchFamily="2" charset="0"/>
               </a:rPr>
@@ -21682,7 +21683,7 @@
             <a:r>
               <a:rPr lang="fr-FR" sz="1300">
                 <a:solidFill>
-                  <a:srgbClr val="9CA9B6"/>
+                  <a:srgbClr val="5F6B76"/>
                 </a:solidFill>
                 <a:latin typeface="Manrope" pitchFamily="2" charset="0"/>
               </a:rPr>
@@ -21713,7 +21714,7 @@
           </a:prstGeom>
           <a:ln w="15875">
             <a:solidFill>
-              <a:srgbClr val="9CA9B6"/>
+              <a:srgbClr val="5F6B76"/>
             </a:solidFill>
             <a:tailEnd type="triangle" w="med" len="med"/>
           </a:ln>
@@ -21769,7 +21770,7 @@
             <a:r>
               <a:rPr lang="fr-FR" sz="1700">
                 <a:solidFill>
-                  <a:srgbClr val="F2F5F8"/>
+                  <a:srgbClr val="1D1D1F"/>
                 </a:solidFill>
                 <a:latin typeface="Manrope Medium" pitchFamily="2" charset="0"/>
               </a:rPr>
@@ -21814,7 +21815,7 @@
             <a:r>
               <a:rPr lang="fr-FR" sz="1300">
                 <a:solidFill>
-                  <a:srgbClr val="9CA9B6"/>
+                  <a:srgbClr val="5F6B76"/>
                 </a:solidFill>
                 <a:latin typeface="Manrope" pitchFamily="2" charset="0"/>
               </a:rPr>
@@ -21859,7 +21860,7 @@
             <a:r>
               <a:rPr lang="fr-FR" sz="1600">
                 <a:solidFill>
-                  <a:srgbClr val="A9CCE3"/>
+                  <a:srgbClr val="24577A"/>
                 </a:solidFill>
                 <a:latin typeface="Manrope Medium" pitchFamily="2" charset="0"/>
               </a:rPr>

</xml_diff>